<commit_message>
Update radar slide to full-screen image without explanations
</commit_message>
<xml_diff>
--- a/AeroVision_Presentation.pptx
+++ b/AeroVision_Presentation.pptx
@@ -7056,45 +7056,9 @@
         <p:nvPr/>
       </p:nvGrpSpPr>
       <p:grpSpPr/>
-      <p:sp>
-        <p:nvSpPr>
-          <p:cNvPr id="2" name="TextBox 1"/>
-          <p:cNvSpPr txBox="1"/>
-          <p:nvPr/>
-        </p:nvSpPr>
-        <p:spPr>
-          <a:xfrm>
-            <a:off x="731520" y="457200"/>
-            <a:ext cx="10728655" cy="731520"/>
-          </a:xfrm>
-          <a:prstGeom prst="rect">
-            <a:avLst/>
-          </a:prstGeom>
-          <a:noFill/>
-        </p:spPr>
-        <p:txBody>
-          <a:bodyPr wrap="square" lIns="0" tIns="0" bIns="0" rIns="0">
-            <a:spAutoFit/>
-          </a:bodyPr>
-          <a:lstStyle/>
-          <a:p>
-            <a:pPr>
-              <a:defRPr sz="3600" b="1">
-                <a:solidFill>
-                  <a:srgbClr val="63B3FF"/>
-                </a:solidFill>
-                <a:latin typeface="Segoe UI"/>
-              </a:defRPr>
-            </a:pPr>
-            <a:r>
-              <a:t>AEROVISION IN ACTION — LIVE RADAR</a:t>
-            </a:r>
-          </a:p>
-        </p:txBody>
-      </p:sp>
       <p:pic>
         <p:nvPicPr>
-          <p:cNvPr id="3" name="Picture 2" descr="media__1785131132189.png"/>
+          <p:cNvPr id="2" name="Picture 1" descr="media__1785131132189.png"/>
           <p:cNvPicPr>
             <a:picLocks noChangeAspect="1"/>
           </p:cNvPicPr>
@@ -7108,133 +7072,14 @@
         </p:blipFill>
         <p:spPr>
           <a:xfrm>
-            <a:off x="731520" y="1645920"/>
-            <a:ext cx="6217920" cy="3497580"/>
+            <a:off x="0" y="0"/>
+            <a:ext cx="12191695" cy="6858000"/>
           </a:xfrm>
           <a:prstGeom prst="rect">
             <a:avLst/>
           </a:prstGeom>
         </p:spPr>
       </p:pic>
-      <p:sp>
-        <p:nvSpPr>
-          <p:cNvPr id="4" name="TextBox 3"/>
-          <p:cNvSpPr txBox="1"/>
-          <p:nvPr/>
-        </p:nvSpPr>
-        <p:spPr>
-          <a:xfrm>
-            <a:off x="7315200" y="1645920"/>
-            <a:ext cx="4144975" cy="4114800"/>
-          </a:xfrm>
-          <a:prstGeom prst="rect">
-            <a:avLst/>
-          </a:prstGeom>
-          <a:noFill/>
-        </p:spPr>
-        <p:txBody>
-          <a:bodyPr wrap="square">
-            <a:spAutoFit/>
-          </a:bodyPr>
-          <a:lstStyle/>
-          <a:p>
-            <a:pPr>
-              <a:spcAft>
-                <a:spcPts val="400"/>
-              </a:spcAft>
-              <a:defRPr sz="1800" b="1">
-                <a:solidFill>
-                  <a:srgbClr val="63B3FF"/>
-                </a:solidFill>
-                <a:latin typeface="Segoe UI"/>
-              </a:defRPr>
-            </a:pPr>
-            <a:r>
-              <a:t>Live Airspace Radar Console</a:t>
-            </a:r>
-          </a:p>
-          <a:p>
-            <a:pPr>
-              <a:spcAft>
-                <a:spcPts val="2000"/>
-              </a:spcAft>
-              <a:defRPr sz="1300">
-                <a:solidFill>
-                  <a:srgbClr val="E8F0FE"/>
-                </a:solidFill>
-                <a:latin typeface="Segoe UI"/>
-              </a:defRPr>
-            </a:pPr>
-            <a:r>
-              <a:t>Direct real-time simulation plots arrivals and departures centered around Bengaluru (VOBL/BLR) airfield airspace.</a:t>
-            </a:r>
-          </a:p>
-          <a:p>
-            <a:pPr>
-              <a:spcAft>
-                <a:spcPts val="400"/>
-              </a:spcAft>
-              <a:defRPr sz="1800" b="1">
-                <a:solidFill>
-                  <a:srgbClr val="63B3FF"/>
-                </a:solidFill>
-                <a:latin typeface="Segoe UI"/>
-              </a:defRPr>
-            </a:pPr>
-            <a:r>
-              <a:t>Active Flight Telemetry</a:t>
-            </a:r>
-          </a:p>
-          <a:p>
-            <a:pPr>
-              <a:spcAft>
-                <a:spcPts val="2000"/>
-              </a:spcAft>
-              <a:defRPr sz="1300">
-                <a:solidFill>
-                  <a:srgbClr val="E8F0FE"/>
-                </a:solidFill>
-                <a:latin typeface="Segoe UI"/>
-              </a:defRPr>
-            </a:pPr>
-            <a:r>
-              <a:t>Clickable flight icons open a detailed sidebar showing origin/destination, gates, terminal slots, and speed vectors.</a:t>
-            </a:r>
-          </a:p>
-          <a:p>
-            <a:pPr>
-              <a:spcAft>
-                <a:spcPts val="400"/>
-              </a:spcAft>
-              <a:defRPr sz="1800" b="1">
-                <a:solidFill>
-                  <a:srgbClr val="63B3FF"/>
-                </a:solidFill>
-                <a:latin typeface="Segoe UI"/>
-              </a:defRPr>
-            </a:pPr>
-            <a:r>
-              <a:t>Dynamic Interpolation Engine</a:t>
-            </a:r>
-          </a:p>
-          <a:p>
-            <a:pPr>
-              <a:spcAft>
-                <a:spcPts val="2000"/>
-              </a:spcAft>
-              <a:defRPr sz="1300">
-                <a:solidFill>
-                  <a:srgbClr val="E8F0FE"/>
-                </a:solidFill>
-                <a:latin typeface="Segoe UI"/>
-              </a:defRPr>
-            </a:pPr>
-            <a:r>
-              <a:t>Automatically switches to schedule-based route math when direct ADS-B coverage is restricted, ensuring 100% demo uptime.</a:t>
-            </a:r>
-          </a:p>
-        </p:txBody>
-      </p:sp>
     </p:spTree>
   </p:cSld>
   <p:clrMapOvr>

</xml_diff>

<commit_message>
Update Slide 8 (Future Enhancements) with custom AI, Beacons, Biometrics, and RFID items
</commit_message>
<xml_diff>
--- a/AeroVision_Presentation.pptx
+++ b/AeroVision_Presentation.pptx
@@ -6787,7 +6787,7 @@
               </a:defRPr>
             </a:pPr>
             <a:r>
-              <a:t>Web Push Notifications</a:t>
+              <a:t>AI Computer Vision Queue Monitoring</a:t>
             </a:r>
           </a:p>
           <a:p>
@@ -6803,7 +6803,7 @@
               </a:defRPr>
             </a:pPr>
             <a:r>
-              <a:t>Integrate the native browser Web Push API to send passengers real-time alerts for gate changes, boarding announcements, and delay notifications directly to their devices.</a:t>
+              <a:t>Integrate airport CCTV cameras with AI object-detection models (like YOLO) to scan video feeds and count the exact number of people in lines, providing 100% accurate queue wait-times.</a:t>
             </a:r>
           </a:p>
         </p:txBody>
@@ -6861,7 +6861,7 @@
               </a:defRPr>
             </a:pPr>
             <a:r>
-              <a:t>Camera-Based Queue Vision</a:t>
+              <a:t>Indoor Turn-by-Turn GPS (Beacons)</a:t>
             </a:r>
           </a:p>
           <a:p>
@@ -6877,7 +6877,7 @@
               </a:defRPr>
             </a:pPr>
             <a:r>
-              <a:t>Implement computer vision models on terminal security cameras to dynamically count queue lengths and calculate wait times automatically instead of relying on passenger load estimates.</a:t>
+              <a:t>Deploy Bluetooth Low Energy (BLE) beacons inside the terminal to enable real-time, blue-dot turn-by-turn navigation guiding passengers from check-in directly to boarding gates.</a:t>
             </a:r>
           </a:p>
         </p:txBody>
@@ -6935,7 +6935,7 @@
               </a:defRPr>
             </a:pPr>
             <a:r>
-              <a:t>Multi-Airport Scalability</a:t>
+              <a:t>DigiYatra / Biometric Integration</a:t>
             </a:r>
           </a:p>
           <a:p>
@@ -6951,7 +6951,7 @@
               </a:defRPr>
             </a:pPr>
             <a:r>
-              <a:t>Expand the platform architecture to cover other major domestic hubs in India (like DEL, BOM, and MAA) by dynamically loading specific SVG terminal maps and airport coordinate databases.</a:t>
+              <a:t>Incorporate facial recognition API endpoints to let passengers authenticate their identity and verify mobility assistance bookings instantly via a quick face scan.</a:t>
             </a:r>
           </a:p>
         </p:txBody>
@@ -7009,7 +7009,7 @@
               </a:defRPr>
             </a:pPr>
             <a:r>
-              <a:t>Offline Terminal Maps</a:t>
+              <a:t>Predictive Baggage Tracking (RFID)</a:t>
             </a:r>
           </a:p>
           <a:p>
@@ -7025,7 +7025,7 @@
               </a:defRPr>
             </a:pPr>
             <a:r>
-              <a:t>Cache SVG blueprints and routing tables in a browser service worker (PWA) so passengers can access indoor maps and pathfinding instructions even when offline inside the terminal.</a:t>
+              <a:t>Utilize IoT RFID luggage tracking to display a live baggage status panel on the passenger dashboard showing exactly where their luggage is (loading, unloading, or carousel).</a:t>
             </a:r>
           </a:p>
         </p:txBody>

</xml_diff>